<commit_message>
Rename coding-service to response-analyser
</commit_message>
<xml_diff>
--- a/assets/figures.pptx
+++ b/assets/figures.pptx
@@ -250,7 +250,7 @@
           <a:p>
             <a:fld id="{C07B6569-5EFF-41A8-B6CB-39864A9A9501}" type="datetimeFigureOut">
               <a:rPr lang="de-DE" smtClean="0"/>
-              <a:t>16.11.2025</a:t>
+              <a:t>24.01.2026</a:t>
             </a:fld>
             <a:endParaRPr lang="de-DE"/>
           </a:p>
@@ -420,7 +420,7 @@
           <a:p>
             <a:fld id="{C07B6569-5EFF-41A8-B6CB-39864A9A9501}" type="datetimeFigureOut">
               <a:rPr lang="de-DE" smtClean="0"/>
-              <a:t>16.11.2025</a:t>
+              <a:t>24.01.2026</a:t>
             </a:fld>
             <a:endParaRPr lang="de-DE"/>
           </a:p>
@@ -600,7 +600,7 @@
           <a:p>
             <a:fld id="{C07B6569-5EFF-41A8-B6CB-39864A9A9501}" type="datetimeFigureOut">
               <a:rPr lang="de-DE" smtClean="0"/>
-              <a:t>16.11.2025</a:t>
+              <a:t>24.01.2026</a:t>
             </a:fld>
             <a:endParaRPr lang="de-DE"/>
           </a:p>
@@ -847,7 +847,7 @@
           <a:p>
             <a:fld id="{C07B6569-5EFF-41A8-B6CB-39864A9A9501}" type="datetimeFigureOut">
               <a:rPr lang="de-DE" smtClean="0"/>
-              <a:t>16.11.2025</a:t>
+              <a:t>24.01.2026</a:t>
             </a:fld>
             <a:endParaRPr lang="de-DE"/>
           </a:p>
@@ -1091,7 +1091,7 @@
           <a:p>
             <a:fld id="{C07B6569-5EFF-41A8-B6CB-39864A9A9501}" type="datetimeFigureOut">
               <a:rPr lang="de-DE" smtClean="0"/>
-              <a:t>16.11.2025</a:t>
+              <a:t>24.01.2026</a:t>
             </a:fld>
             <a:endParaRPr lang="de-DE"/>
           </a:p>
@@ -1323,7 +1323,7 @@
           <a:p>
             <a:fld id="{C07B6569-5EFF-41A8-B6CB-39864A9A9501}" type="datetimeFigureOut">
               <a:rPr lang="de-DE" smtClean="0"/>
-              <a:t>16.11.2025</a:t>
+              <a:t>24.01.2026</a:t>
             </a:fld>
             <a:endParaRPr lang="de-DE"/>
           </a:p>
@@ -1690,7 +1690,7 @@
           <a:p>
             <a:fld id="{C07B6569-5EFF-41A8-B6CB-39864A9A9501}" type="datetimeFigureOut">
               <a:rPr lang="de-DE" smtClean="0"/>
-              <a:t>16.11.2025</a:t>
+              <a:t>24.01.2026</a:t>
             </a:fld>
             <a:endParaRPr lang="de-DE"/>
           </a:p>
@@ -1808,7 +1808,7 @@
           <a:p>
             <a:fld id="{C07B6569-5EFF-41A8-B6CB-39864A9A9501}" type="datetimeFigureOut">
               <a:rPr lang="de-DE" smtClean="0"/>
-              <a:t>16.11.2025</a:t>
+              <a:t>24.01.2026</a:t>
             </a:fld>
             <a:endParaRPr lang="de-DE"/>
           </a:p>
@@ -1903,7 +1903,7 @@
           <a:p>
             <a:fld id="{C07B6569-5EFF-41A8-B6CB-39864A9A9501}" type="datetimeFigureOut">
               <a:rPr lang="de-DE" smtClean="0"/>
-              <a:t>16.11.2025</a:t>
+              <a:t>24.01.2026</a:t>
             </a:fld>
             <a:endParaRPr lang="de-DE"/>
           </a:p>
@@ -2180,7 +2180,7 @@
           <a:p>
             <a:fld id="{C07B6569-5EFF-41A8-B6CB-39864A9A9501}" type="datetimeFigureOut">
               <a:rPr lang="de-DE" smtClean="0"/>
-              <a:t>16.11.2025</a:t>
+              <a:t>24.01.2026</a:t>
             </a:fld>
             <a:endParaRPr lang="de-DE"/>
           </a:p>
@@ -2437,7 +2437,7 @@
           <a:p>
             <a:fld id="{C07B6569-5EFF-41A8-B6CB-39864A9A9501}" type="datetimeFigureOut">
               <a:rPr lang="de-DE" smtClean="0"/>
-              <a:t>16.11.2025</a:t>
+              <a:t>24.01.2026</a:t>
             </a:fld>
             <a:endParaRPr lang="de-DE"/>
           </a:p>
@@ -2650,7 +2650,7 @@
           <a:p>
             <a:fld id="{C07B6569-5EFF-41A8-B6CB-39864A9A9501}" type="datetimeFigureOut">
               <a:rPr lang="de-DE" smtClean="0"/>
-              <a:t>16.11.2025</a:t>
+              <a:t>24.01.2026</a:t>
             </a:fld>
             <a:endParaRPr lang="de-DE"/>
           </a:p>
@@ -5222,7 +5222,7 @@
             <a:pPr algn="ctr"/>
             <a:r>
               <a:rPr lang="de-DE" sz="1200"/>
-              <a:t>IQB-CodingService</a:t>
+              <a:t>IQB-ResponseAnalyser</a:t>
             </a:r>
           </a:p>
         </p:txBody>
@@ -6942,7 +6942,7 @@
           <a:p>
             <a:r>
               <a:rPr lang="de-DE"/>
-              <a:t>coding-service.png</a:t>
+              <a:t>response-analyser.png</a:t>
             </a:r>
           </a:p>
         </p:txBody>
@@ -7612,62 +7612,6 @@
       </p:sp>
       <p:sp>
         <p:nvSpPr>
-          <p:cNvPr id="24" name="Rechteck: abgerundete Ecken 23">
-            <a:extLst>
-              <a:ext uri="{FF2B5EF4-FFF2-40B4-BE49-F238E27FC236}">
-                <a16:creationId xmlns:a16="http://schemas.microsoft.com/office/drawing/2014/main" id="{55A149B1-1B8A-4A2A-A04E-957240767D97}"/>
-              </a:ext>
-            </a:extLst>
-          </p:cNvPr>
-          <p:cNvSpPr/>
-          <p:nvPr/>
-        </p:nvSpPr>
-        <p:spPr>
-          <a:xfrm>
-            <a:off x="2471151" y="1785355"/>
-            <a:ext cx="1676257" cy="318109"/>
-          </a:xfrm>
-          <a:prstGeom prst="roundRect">
-            <a:avLst/>
-          </a:prstGeom>
-          <a:solidFill>
-            <a:srgbClr val="008CBA"/>
-          </a:solidFill>
-          <a:ln>
-            <a:noFill/>
-          </a:ln>
-        </p:spPr>
-        <p:style>
-          <a:lnRef idx="2">
-            <a:schemeClr val="accent1">
-              <a:shade val="50000"/>
-            </a:schemeClr>
-          </a:lnRef>
-          <a:fillRef idx="1">
-            <a:schemeClr val="accent1"/>
-          </a:fillRef>
-          <a:effectRef idx="0">
-            <a:schemeClr val="accent1"/>
-          </a:effectRef>
-          <a:fontRef idx="minor">
-            <a:schemeClr val="lt1"/>
-          </a:fontRef>
-        </p:style>
-        <p:txBody>
-          <a:bodyPr rtlCol="0" anchor="ctr"/>
-          <a:lstStyle/>
-          <a:p>
-            <a:pPr algn="ctr"/>
-            <a:r>
-              <a:rPr lang="de-DE" sz="1400"/>
-              <a:t>IQB-Testcenter</a:t>
-            </a:r>
-            <a:endParaRPr lang="de-DE"/>
-          </a:p>
-        </p:txBody>
-      </p:sp>
-      <p:sp>
-        <p:nvSpPr>
           <p:cNvPr id="26" name="Rechteck 25">
             <a:extLst>
               <a:ext uri="{FF2B5EF4-FFF2-40B4-BE49-F238E27FC236}">
@@ -7719,8 +7663,29 @@
                   <a:srgbClr val="405786"/>
                 </a:solidFill>
               </a:rPr>
-              <a:t>Survey Content Package</a:t>
-            </a:r>
+              <a:t>Assessment Content Package</a:t>
+            </a:r>
+          </a:p>
+          <a:p>
+            <a:endParaRPr lang="de-DE" sz="1600">
+              <a:solidFill>
+                <a:srgbClr val="405786"/>
+              </a:solidFill>
+            </a:endParaRPr>
+          </a:p>
+          <a:p>
+            <a:endParaRPr lang="de-DE" sz="1600">
+              <a:solidFill>
+                <a:srgbClr val="405786"/>
+              </a:solidFill>
+            </a:endParaRPr>
+          </a:p>
+          <a:p>
+            <a:endParaRPr lang="de-DE" sz="1600">
+              <a:solidFill>
+                <a:srgbClr val="405786"/>
+              </a:solidFill>
+            </a:endParaRPr>
           </a:p>
         </p:txBody>
       </p:sp>
@@ -8548,7 +8513,7 @@
           <a:p>
             <a:r>
               <a:rPr lang="de-DE"/>
-              <a:t>coding-service-vera.png</a:t>
+              <a:t>response-analyser-vera.png</a:t>
             </a:r>
           </a:p>
         </p:txBody>
@@ -8629,8 +8594,8 @@
         </p:nvSpPr>
         <p:spPr>
           <a:xfrm>
-            <a:off x="842318" y="2938048"/>
-            <a:ext cx="1676257" cy="566909"/>
+            <a:off x="584462" y="2938048"/>
+            <a:ext cx="1934113" cy="566909"/>
           </a:xfrm>
           <a:prstGeom prst="roundRect">
             <a:avLst/>
@@ -8685,8 +8650,8 @@
         </p:nvSpPr>
         <p:spPr>
           <a:xfrm>
-            <a:off x="842318" y="3776488"/>
-            <a:ext cx="1676257" cy="961458"/>
+            <a:off x="584462" y="3776488"/>
+            <a:ext cx="1934114" cy="961458"/>
           </a:xfrm>
           <a:prstGeom prst="roundRect">
             <a:avLst/>
@@ -8721,7 +8686,7 @@
             <a:pPr algn="ctr"/>
             <a:r>
               <a:rPr lang="de-DE" sz="1400"/>
-              <a:t>IQB-CodingService</a:t>
+              <a:t>IQB-ResponseAnalyser</a:t>
             </a:r>
             <a:endParaRPr lang="de-DE"/>
           </a:p>
@@ -9569,8 +9534,8 @@
         </p:nvSpPr>
         <p:spPr>
           <a:xfrm>
-            <a:off x="842318" y="2128711"/>
-            <a:ext cx="1676257" cy="566909"/>
+            <a:off x="584462" y="2128711"/>
+            <a:ext cx="1934113" cy="566909"/>
           </a:xfrm>
           <a:prstGeom prst="roundRect">
             <a:avLst/>
@@ -9986,7 +9951,7 @@
           <a:p>
             <a:r>
               <a:rPr lang="de-DE"/>
-              <a:t>coding-service-stars.png</a:t>
+              <a:t>response-analyser-stars.png</a:t>
             </a:r>
           </a:p>
         </p:txBody>
@@ -10067,8 +10032,8 @@
         </p:nvSpPr>
         <p:spPr>
           <a:xfrm>
-            <a:off x="842318" y="2938048"/>
-            <a:ext cx="1676257" cy="566909"/>
+            <a:off x="565608" y="2938048"/>
+            <a:ext cx="1952967" cy="566909"/>
           </a:xfrm>
           <a:prstGeom prst="roundRect">
             <a:avLst/>
@@ -10123,8 +10088,8 @@
         </p:nvSpPr>
         <p:spPr>
           <a:xfrm>
-            <a:off x="842318" y="3776488"/>
-            <a:ext cx="1676257" cy="961458"/>
+            <a:off x="565608" y="3776488"/>
+            <a:ext cx="1952967" cy="961458"/>
           </a:xfrm>
           <a:prstGeom prst="roundRect">
             <a:avLst/>
@@ -10159,7 +10124,7 @@
             <a:pPr algn="ctr"/>
             <a:r>
               <a:rPr lang="de-DE" sz="1400"/>
-              <a:t>IQB-CodingService</a:t>
+              <a:t>IQB-ResponseAnalyser</a:t>
             </a:r>
             <a:endParaRPr lang="de-DE"/>
           </a:p>
@@ -10843,8 +10808,8 @@
         </p:nvSpPr>
         <p:spPr>
           <a:xfrm>
-            <a:off x="842318" y="2128711"/>
-            <a:ext cx="1676257" cy="566909"/>
+            <a:off x="565608" y="2128711"/>
+            <a:ext cx="1952967" cy="566909"/>
           </a:xfrm>
           <a:prstGeom prst="roundRect">
             <a:avLst/>

</xml_diff>